<commit_message>
feat(deck): replace slide deck with Mitra's revision (transitions added)
</commit_message>
<xml_diff>
--- a/deck/presentation.pptx
+++ b/deck/presentation.pptx
@@ -4508,10 +4508,14 @@
   </p:cSld>
   <mc:AlternateContent>
     <mc:Choice Requires="p14">
-      <p:transition spd="slow" p14:dur="2000"/>
+      <p:transition spd="med" p14:dur="1500">
+        <p14:ferris dir="l"/>
+      </p:transition>
     </mc:Choice>
     <mc:Fallback>
-      <p:transition spd="slow"/>
+      <p:transition spd="med">
+        <p:fade/>
+      </p:transition>
     </mc:Fallback>
   </mc:AlternateContent>
 </p:sld>
@@ -5578,10 +5582,14 @@
   </p:cSld>
   <mc:AlternateContent>
     <mc:Choice Requires="p14">
-      <p:transition spd="slow" p14:dur="2000"/>
+      <p:transition spd="med" p14:dur="1500">
+        <p14:doors dir="horz"/>
+      </p:transition>
     </mc:Choice>
     <mc:Fallback>
-      <p:transition spd="slow"/>
+      <p:transition spd="med">
+        <p:fade/>
+      </p:transition>
     </mc:Fallback>
   </mc:AlternateContent>
 </p:sld>
@@ -6689,10 +6697,14 @@
   </p:cSld>
   <mc:AlternateContent>
     <mc:Choice Requires="p14">
-      <p:transition spd="slow" p14:dur="2000"/>
+      <p:transition spd="med" p14:dur="1500">
+        <p14:prism dir="l"/>
+      </p:transition>
     </mc:Choice>
     <mc:Fallback>
-      <p:transition spd="slow"/>
+      <p:transition spd="med">
+        <p:fade/>
+      </p:transition>
     </mc:Fallback>
   </mc:AlternateContent>
 </p:sld>
@@ -8127,10 +8139,14 @@
   </p:cSld>
   <mc:AlternateContent>
     <mc:Choice Requires="p14">
-      <p:transition spd="slow" p14:dur="2000"/>
+      <p:transition spd="med" p14:dur="1500">
+        <p14:gallery dir="r"/>
+      </p:transition>
     </mc:Choice>
     <mc:Fallback>
-      <p:transition spd="slow"/>
+      <p:transition spd="med">
+        <p:fade/>
+      </p:transition>
     </mc:Fallback>
   </mc:AlternateContent>
 </p:sld>
@@ -8790,10 +8806,14 @@
   </p:cSld>
   <mc:AlternateContent>
     <mc:Choice Requires="p14">
-      <p:transition spd="slow" p14:dur="2000"/>
+      <p:transition spd="med" p14:dur="1500">
+        <p14:vortex dir="l"/>
+      </p:transition>
     </mc:Choice>
     <mc:Fallback>
-      <p:transition spd="slow"/>
+      <p:transition spd="med">
+        <p:fade/>
+      </p:transition>
     </mc:Fallback>
   </mc:AlternateContent>
 </p:sld>

</xml_diff>